<commit_message>
Update Defect-to-Delivery presentation slides
</commit_message>
<xml_diff>
--- a/slides/Defect-to-Delivery_262-034.pptx
+++ b/slides/Defect-to-Delivery_262-034.pptx
@@ -5344,8 +5344,8 @@
         </p:nvSpPr>
         <p:spPr>
           <a:xfrm>
-            <a:off x="548640" y="1952935"/>
-            <a:ext cx="2651760" cy="1835147"/>
+            <a:off x="548640" y="1953158"/>
+            <a:ext cx="2651760" cy="2199132"/>
           </a:xfrm>
           <a:prstGeom prst="roundRect">
             <a:avLst>
@@ -5392,7 +5392,7 @@
         </p:nvSpPr>
         <p:spPr>
           <a:xfrm>
-            <a:off x="804672" y="2040508"/>
+            <a:off x="804672" y="2227478"/>
             <a:ext cx="475488" cy="475488"/>
           </a:xfrm>
           <a:prstGeom prst="ellipse">
@@ -5444,8 +5444,8 @@
         </p:nvSpPr>
         <p:spPr>
           <a:xfrm>
-            <a:off x="1417319" y="2003932"/>
-            <a:ext cx="1600200" cy="1464446"/>
+            <a:off x="1417320" y="2209190"/>
+            <a:ext cx="1609343" cy="1860803"/>
           </a:xfrm>
           <a:prstGeom prst="rect">
             <a:avLst/>
@@ -5496,8 +5496,8 @@
         </p:nvSpPr>
         <p:spPr>
           <a:xfrm>
-            <a:off x="3328416" y="1952935"/>
-            <a:ext cx="2651760" cy="1835147"/>
+            <a:off x="3328416" y="1953158"/>
+            <a:ext cx="2651760" cy="2199132"/>
           </a:xfrm>
           <a:prstGeom prst="roundRect">
             <a:avLst>
@@ -5544,7 +5544,7 @@
         </p:nvSpPr>
         <p:spPr>
           <a:xfrm>
-            <a:off x="3584448" y="1835473"/>
+            <a:off x="3584448" y="2227478"/>
             <a:ext cx="475488" cy="475488"/>
           </a:xfrm>
           <a:prstGeom prst="ellipse">
@@ -5596,8 +5596,8 @@
         </p:nvSpPr>
         <p:spPr>
           <a:xfrm>
-            <a:off x="4197096" y="1798897"/>
-            <a:ext cx="1600200" cy="1874519"/>
+            <a:off x="4197096" y="2209190"/>
+            <a:ext cx="1609343" cy="1860803"/>
           </a:xfrm>
           <a:prstGeom prst="rect">
             <a:avLst/>
@@ -5648,8 +5648,8 @@
         </p:nvSpPr>
         <p:spPr>
           <a:xfrm>
-            <a:off x="6108192" y="1952935"/>
-            <a:ext cx="2651760" cy="1835147"/>
+            <a:off x="6108192" y="1953158"/>
+            <a:ext cx="2651760" cy="2199132"/>
           </a:xfrm>
           <a:prstGeom prst="roundRect">
             <a:avLst>
@@ -5696,7 +5696,7 @@
         </p:nvSpPr>
         <p:spPr>
           <a:xfrm>
-            <a:off x="6364224" y="1835473"/>
+            <a:off x="6364224" y="2227478"/>
             <a:ext cx="475488" cy="475488"/>
           </a:xfrm>
           <a:prstGeom prst="ellipse">
@@ -5748,8 +5748,8 @@
         </p:nvSpPr>
         <p:spPr>
           <a:xfrm>
-            <a:off x="6976872" y="1798897"/>
-            <a:ext cx="1600200" cy="1874519"/>
+            <a:off x="6976872" y="2209190"/>
+            <a:ext cx="1609343" cy="1632204"/>
           </a:xfrm>
           <a:prstGeom prst="rect">
             <a:avLst/>
@@ -5800,8 +5800,8 @@
         </p:nvSpPr>
         <p:spPr>
           <a:xfrm>
-            <a:off x="8887968" y="1952935"/>
-            <a:ext cx="2651760" cy="1835147"/>
+            <a:off x="8887968" y="1953158"/>
+            <a:ext cx="2651760" cy="2199132"/>
           </a:xfrm>
           <a:prstGeom prst="roundRect">
             <a:avLst>
@@ -5848,7 +5848,7 @@
         </p:nvSpPr>
         <p:spPr>
           <a:xfrm>
-            <a:off x="9144000" y="1835473"/>
+            <a:off x="9144000" y="2227478"/>
             <a:ext cx="475488" cy="475488"/>
           </a:xfrm>
           <a:prstGeom prst="ellipse">
@@ -5900,8 +5900,8 @@
         </p:nvSpPr>
         <p:spPr>
           <a:xfrm>
-            <a:off x="9756648" y="1798897"/>
-            <a:ext cx="1600200" cy="1874519"/>
+            <a:off x="9756648" y="2209190"/>
+            <a:ext cx="1609343" cy="1632204"/>
           </a:xfrm>
           <a:prstGeom prst="rect">
             <a:avLst/>
@@ -6064,7 +6064,7 @@
         </p:nvGraphicFramePr>
         <p:xfrm>
           <a:off x="548640" y="1234440"/>
-          <a:ext cx="11064240" cy="3072384"/>
+          <a:ext cx="11064240" cy="3017520"/>
         </p:xfrm>
         <a:graphic>
           <a:graphicData uri="http://schemas.openxmlformats.org/drawingml/2006/table">
@@ -6073,42 +6073,42 @@
                 <a:tableStyleId>{5C22544A-7EE6-4342-B048-85BDC9FD1C3A}</a:tableStyleId>
               </a:tblPr>
               <a:tblGrid>
-                <a:gridCol w="1580605">
+                <a:gridCol w="1600200">
                   <a:extLst>
                     <a:ext uri="{9D8B030D-6E8A-4147-A177-3AD203B41FA5}">
                       <a16:colId xmlns:a16="http://schemas.microsoft.com/office/drawing/2014/main" val="20000"/>
                     </a:ext>
                   </a:extLst>
                 </a:gridCol>
-                <a:gridCol w="1580605">
+                <a:gridCol w="960120">
                   <a:extLst>
                     <a:ext uri="{9D8B030D-6E8A-4147-A177-3AD203B41FA5}">
                       <a16:colId xmlns:a16="http://schemas.microsoft.com/office/drawing/2014/main" val="20001"/>
                     </a:ext>
                   </a:extLst>
                 </a:gridCol>
-                <a:gridCol w="1580605">
+                <a:gridCol w="1325880">
                   <a:extLst>
                     <a:ext uri="{9D8B030D-6E8A-4147-A177-3AD203B41FA5}">
                       <a16:colId xmlns:a16="http://schemas.microsoft.com/office/drawing/2014/main" val="20003"/>
                     </a:ext>
                   </a:extLst>
                 </a:gridCol>
-                <a:gridCol w="1580605">
+                <a:gridCol w="1600200">
                   <a:extLst>
                     <a:ext uri="{9D8B030D-6E8A-4147-A177-3AD203B41FA5}">
                       <a16:colId xmlns:a16="http://schemas.microsoft.com/office/drawing/2014/main" val="20004"/>
                     </a:ext>
                   </a:extLst>
                 </a:gridCol>
-                <a:gridCol w="1580605">
+                <a:gridCol w="1325880">
                   <a:extLst>
                     <a:ext uri="{9D8B030D-6E8A-4147-A177-3AD203B41FA5}">
                       <a16:colId xmlns:a16="http://schemas.microsoft.com/office/drawing/2014/main" val="20005"/>
                     </a:ext>
                   </a:extLst>
                 </a:gridCol>
-                <a:gridCol w="1580610">
+                <a:gridCol w="4251960">
                   <a:extLst>
                     <a:ext uri="{9D8B030D-6E8A-4147-A177-3AD203B41FA5}">
                       <a16:colId xmlns:a16="http://schemas.microsoft.com/office/drawing/2014/main" val="20006"/>
@@ -6116,7 +6116,7 @@
                   </a:extLst>
                 </a:gridCol>
               </a:tblGrid>
-              <a:tr h="384048">
+              <a:tr h="350215">
                 <a:tc>
                   <a:txBody>
                     <a:bodyPr wrap="square" lIns="54864" rIns="54864" tIns="27432" bIns="27432" anchor="ctr"/>
@@ -6261,7 +6261,7 @@
                   </a:ext>
                 </a:extLst>
               </a:tr>
-              <a:tr h="384048">
+              <a:tr h="350215">
                 <a:tc>
                   <a:txBody>
                     <a:bodyPr wrap="square" lIns="54864" rIns="54864" tIns="27432" bIns="27432" anchor="ctr"/>
@@ -6406,7 +6406,7 @@
                   </a:ext>
                 </a:extLst>
               </a:tr>
-              <a:tr h="384048">
+              <a:tr h="350215">
                 <a:tc>
                   <a:txBody>
                     <a:bodyPr wrap="square" lIns="54864" rIns="54864" tIns="27432" bIns="27432" anchor="ctr"/>
@@ -6551,7 +6551,7 @@
                   </a:ext>
                 </a:extLst>
               </a:tr>
-              <a:tr h="384048">
+              <a:tr h="350215">
                 <a:tc>
                   <a:txBody>
                     <a:bodyPr wrap="square" lIns="54864" rIns="54864" tIns="27432" bIns="27432" anchor="ctr"/>
@@ -6696,7 +6696,7 @@
                   </a:ext>
                 </a:extLst>
               </a:tr>
-              <a:tr h="384048">
+              <a:tr h="350215">
                 <a:tc>
                   <a:txBody>
                     <a:bodyPr wrap="square" lIns="54864" rIns="54864" tIns="27432" bIns="27432" anchor="ctr"/>
@@ -6841,7 +6841,7 @@
                   </a:ext>
                 </a:extLst>
               </a:tr>
-              <a:tr h="384048">
+              <a:tr h="350215">
                 <a:tc>
                   <a:txBody>
                     <a:bodyPr wrap="square" lIns="54864" rIns="54864" tIns="27432" bIns="27432" anchor="ctr"/>
@@ -6986,7 +6986,7 @@
                   </a:ext>
                 </a:extLst>
               </a:tr>
-              <a:tr h="384048">
+              <a:tr h="564184">
                 <a:tc>
                   <a:txBody>
                     <a:bodyPr wrap="square" lIns="54864" rIns="54864" tIns="27432" bIns="27432" anchor="ctr"/>
@@ -7131,7 +7131,7 @@
                   </a:ext>
                 </a:extLst>
               </a:tr>
-              <a:tr h="384048">
+              <a:tr h="350215">
                 <a:tc>
                   <a:txBody>
                     <a:bodyPr wrap="square" lIns="54864" rIns="54864" tIns="27432" bIns="27432" anchor="ctr"/>
@@ -7461,7 +7461,7 @@
         <p:spPr>
           <a:xfrm>
             <a:off x="548640" y="320040"/>
-            <a:ext cx="11064240" cy="914400"/>
+            <a:ext cx="11064240" cy="628192"/>
           </a:xfrm>
           <a:prstGeom prst="rect">
             <a:avLst/>
@@ -8685,7 +8685,7 @@
         </p:nvGraphicFramePr>
         <p:xfrm>
           <a:off x="548640" y="3035808"/>
-          <a:ext cx="5623560" cy="2889504"/>
+          <a:ext cx="5623560" cy="3072384"/>
         </p:xfrm>
         <a:graphic>
           <a:graphicData uri="http://schemas.openxmlformats.org/drawingml/2006/table">
@@ -8695,7 +8695,7 @@
                 <a:gridCol w="749808"/>
                 <a:gridCol w="4873752"/>
               </a:tblGrid>
-              <a:tr h="361188">
+              <a:tr h="384048">
                 <a:tc>
                   <a:txBody>
                     <a:bodyPr wrap="square"/>
@@ -8751,7 +8751,7 @@
                   </a:tcPr>
                 </a:tc>
               </a:tr>
-              <a:tr h="361188">
+              <a:tr h="384048">
                 <a:tc>
                   <a:txBody>
                     <a:bodyPr wrap="square"/>
@@ -8807,7 +8807,7 @@
                   </a:tcPr>
                 </a:tc>
               </a:tr>
-              <a:tr h="361188">
+              <a:tr h="384048">
                 <a:tc>
                   <a:txBody>
                     <a:bodyPr wrap="square"/>
@@ -8863,7 +8863,7 @@
                   </a:tcPr>
                 </a:tc>
               </a:tr>
-              <a:tr h="361188">
+              <a:tr h="384048">
                 <a:tc>
                   <a:txBody>
                     <a:bodyPr wrap="square"/>
@@ -8919,7 +8919,7 @@
                   </a:tcPr>
                 </a:tc>
               </a:tr>
-              <a:tr h="361188">
+              <a:tr h="384048">
                 <a:tc>
                   <a:txBody>
                     <a:bodyPr wrap="square"/>
@@ -8975,7 +8975,7 @@
                   </a:tcPr>
                 </a:tc>
               </a:tr>
-              <a:tr h="361188">
+              <a:tr h="384048">
                 <a:tc>
                   <a:txBody>
                     <a:bodyPr wrap="square"/>
@@ -9031,7 +9031,7 @@
                   </a:tcPr>
                 </a:tc>
               </a:tr>
-              <a:tr h="361188">
+              <a:tr h="384048">
                 <a:tc>
                   <a:txBody>
                     <a:bodyPr wrap="square"/>
@@ -9087,7 +9087,7 @@
                   </a:tcPr>
                 </a:tc>
               </a:tr>
-              <a:tr h="361188">
+              <a:tr h="384048">
                 <a:tc>
                   <a:txBody>
                     <a:bodyPr wrap="square"/>
@@ -9156,18 +9156,18 @@
           <p:nvPr/>
         </p:nvGraphicFramePr>
         <p:xfrm>
-          <a:off x="6016752" y="3035808"/>
-          <a:ext cx="5623560" cy="3017520"/>
+          <a:off x="6199632" y="3035808"/>
+          <a:ext cx="5623560" cy="3072384"/>
         </p:xfrm>
         <a:graphic>
           <a:graphicData uri="http://schemas.openxmlformats.org/drawingml/2006/table">
             <a:tbl>
               <a:tblPr firstRow="0" bandRow="0"/>
               <a:tblGrid>
-                <a:gridCol w="868680"/>
-                <a:gridCol w="4754880"/>
+                <a:gridCol w="749808"/>
+                <a:gridCol w="4873752"/>
               </a:tblGrid>
-              <a:tr h="502920">
+              <a:tr h="384048">
                 <a:tc>
                   <a:txBody>
                     <a:bodyPr wrap="square"/>
@@ -9223,7 +9223,7 @@
                   </a:tcPr>
                 </a:tc>
               </a:tr>
-              <a:tr h="502920">
+              <a:tr h="537667">
                 <a:tc>
                   <a:txBody>
                     <a:bodyPr wrap="square"/>
@@ -9279,7 +9279,7 @@
                   </a:tcPr>
                 </a:tc>
               </a:tr>
-              <a:tr h="502920">
+              <a:tr h="537667">
                 <a:tc>
                   <a:txBody>
                     <a:bodyPr wrap="square"/>
@@ -9335,7 +9335,7 @@
                   </a:tcPr>
                 </a:tc>
               </a:tr>
-              <a:tr h="502920">
+              <a:tr h="537667">
                 <a:tc>
                   <a:txBody>
                     <a:bodyPr wrap="square"/>
@@ -9391,7 +9391,7 @@
                   </a:tcPr>
                 </a:tc>
               </a:tr>
-              <a:tr h="502920">
+              <a:tr h="537667">
                 <a:tc>
                   <a:txBody>
                     <a:bodyPr wrap="square"/>
@@ -9447,7 +9447,7 @@
                   </a:tcPr>
                 </a:tc>
               </a:tr>
-              <a:tr h="502920">
+              <a:tr h="537667">
                 <a:tc>
                   <a:txBody>
                     <a:bodyPr wrap="square"/>
@@ -9515,8 +9515,8 @@
         </p:nvSpPr>
         <p:spPr>
           <a:xfrm>
-            <a:off x="548640" y="6053328"/>
-            <a:ext cx="11091672" cy="274320"/>
+            <a:off x="548640" y="6132880"/>
+            <a:ext cx="11091672" cy="231343"/>
           </a:xfrm>
           <a:prstGeom prst="rect">
             <a:avLst/>
@@ -9584,7 +9584,7 @@
         <p:spPr>
           <a:xfrm>
             <a:off x="411480" y="228600"/>
-            <a:ext cx="7315200" cy="457200"/>
+            <a:ext cx="7315200" cy="536752"/>
           </a:xfrm>
           <a:prstGeom prst="rect">
             <a:avLst/>
@@ -9754,7 +9754,7 @@
         <p:spPr>
           <a:xfrm>
             <a:off x="411480" y="228600"/>
-            <a:ext cx="7315200" cy="457200"/>
+            <a:ext cx="7315200" cy="536752"/>
           </a:xfrm>
           <a:prstGeom prst="rect">
             <a:avLst/>
@@ -9924,7 +9924,7 @@
         <p:spPr>
           <a:xfrm>
             <a:off x="411480" y="228600"/>
-            <a:ext cx="7315200" cy="457200"/>
+            <a:ext cx="7315200" cy="536752"/>
           </a:xfrm>
           <a:prstGeom prst="rect">
             <a:avLst/>
@@ -10094,7 +10094,7 @@
         <p:spPr>
           <a:xfrm>
             <a:off x="411480" y="228600"/>
-            <a:ext cx="7315200" cy="457200"/>
+            <a:ext cx="7315200" cy="536752"/>
           </a:xfrm>
           <a:prstGeom prst="rect">
             <a:avLst/>
@@ -10270,7 +10270,7 @@
         <p:spPr>
           <a:xfrm>
             <a:off x="411480" y="228600"/>
-            <a:ext cx="7315200" cy="457200"/>
+            <a:ext cx="7315200" cy="536752"/>
           </a:xfrm>
           <a:prstGeom prst="rect">
             <a:avLst/>
@@ -10544,8 +10544,8 @@
         </p:nvSpPr>
         <p:spPr>
           <a:xfrm>
-            <a:off x="1729564" y="1402650"/>
-            <a:ext cx="3337559" cy="1555244"/>
+            <a:off x="548640" y="1344168"/>
+            <a:ext cx="5394960" cy="1337767"/>
           </a:xfrm>
           <a:prstGeom prst="roundRect">
             <a:avLst>
@@ -10592,7 +10592,7 @@
         </p:nvSpPr>
         <p:spPr>
           <a:xfrm>
-            <a:off x="1985597" y="1695641"/>
+            <a:off x="804672" y="1581912"/>
             <a:ext cx="475488" cy="475488"/>
           </a:xfrm>
           <a:prstGeom prst="ellipse">
@@ -10644,8 +10644,8 @@
         </p:nvSpPr>
         <p:spPr>
           <a:xfrm>
-            <a:off x="2835075" y="1659065"/>
-            <a:ext cx="1783080" cy="1143000"/>
+            <a:off x="1965960" y="1563624"/>
+            <a:ext cx="3767328" cy="962863"/>
           </a:xfrm>
           <a:prstGeom prst="rect">
             <a:avLst/>
@@ -10712,8 +10712,8 @@
         </p:nvSpPr>
         <p:spPr>
           <a:xfrm>
-            <a:off x="6521959" y="1402650"/>
-            <a:ext cx="3337558" cy="1555244"/>
+            <a:off x="6245352" y="1344168"/>
+            <a:ext cx="5394960" cy="1337767"/>
           </a:xfrm>
           <a:prstGeom prst="roundRect">
             <a:avLst>
@@ -10760,8 +10760,8 @@
         </p:nvSpPr>
         <p:spPr>
           <a:xfrm>
-            <a:off x="6895949" y="1618488"/>
-            <a:ext cx="523037" cy="475488"/>
+            <a:off x="6501384" y="1581912"/>
+            <a:ext cx="475488" cy="475488"/>
           </a:xfrm>
           <a:prstGeom prst="ellipse">
             <a:avLst/>
@@ -10812,8 +10812,8 @@
         </p:nvSpPr>
         <p:spPr>
           <a:xfrm>
-            <a:off x="7731252" y="1613916"/>
-            <a:ext cx="1961388" cy="1143000"/>
+            <a:off x="7662672" y="1563624"/>
+            <a:ext cx="3767328" cy="962863"/>
           </a:xfrm>
           <a:prstGeom prst="rect">
             <a:avLst/>
@@ -10880,8 +10880,8 @@
         </p:nvSpPr>
         <p:spPr>
           <a:xfrm>
-            <a:off x="548640" y="3040295"/>
-            <a:ext cx="3520440" cy="1554648"/>
+            <a:off x="548640" y="2791663"/>
+            <a:ext cx="3520440" cy="1542592"/>
           </a:xfrm>
           <a:prstGeom prst="roundRect">
             <a:avLst>
@@ -10928,7 +10928,7 @@
         </p:nvSpPr>
         <p:spPr>
           <a:xfrm>
-            <a:off x="804672" y="3401568"/>
+            <a:off x="804672" y="3029407"/>
             <a:ext cx="475488" cy="475488"/>
           </a:xfrm>
           <a:prstGeom prst="ellipse">
@@ -10980,8 +10980,8 @@
         </p:nvSpPr>
         <p:spPr>
           <a:xfrm>
-            <a:off x="1417319" y="3364991"/>
-            <a:ext cx="2468880" cy="1005840"/>
+            <a:off x="1417320" y="3011119"/>
+            <a:ext cx="2441448" cy="1167688"/>
           </a:xfrm>
           <a:prstGeom prst="rect">
             <a:avLst/>
@@ -11048,8 +11048,8 @@
         </p:nvSpPr>
         <p:spPr>
           <a:xfrm>
-            <a:off x="4251959" y="3040295"/>
-            <a:ext cx="3520440" cy="1554648"/>
+            <a:off x="4251959" y="2791663"/>
+            <a:ext cx="3520440" cy="1542592"/>
           </a:xfrm>
           <a:prstGeom prst="roundRect">
             <a:avLst>
@@ -11096,7 +11096,7 @@
         </p:nvSpPr>
         <p:spPr>
           <a:xfrm>
-            <a:off x="4507992" y="3401568"/>
+            <a:off x="4507992" y="3029407"/>
             <a:ext cx="475488" cy="475488"/>
           </a:xfrm>
           <a:prstGeom prst="ellipse">
@@ -11148,8 +11148,8 @@
         </p:nvSpPr>
         <p:spPr>
           <a:xfrm>
-            <a:off x="5120640" y="3364991"/>
-            <a:ext cx="2468880" cy="1005840"/>
+            <a:off x="5120640" y="3011119"/>
+            <a:ext cx="2441448" cy="1167688"/>
           </a:xfrm>
           <a:prstGeom prst="rect">
             <a:avLst/>
@@ -11223,8 +11223,8 @@
         </p:nvSpPr>
         <p:spPr>
           <a:xfrm>
-            <a:off x="7955279" y="3040295"/>
-            <a:ext cx="3520440" cy="1554648"/>
+            <a:off x="7955279" y="2791663"/>
+            <a:ext cx="3520440" cy="1542592"/>
           </a:xfrm>
           <a:prstGeom prst="roundRect">
             <a:avLst>
@@ -11271,7 +11271,7 @@
         </p:nvSpPr>
         <p:spPr>
           <a:xfrm>
-            <a:off x="8211311" y="3401568"/>
+            <a:off x="8211312" y="3029407"/>
             <a:ext cx="475488" cy="475488"/>
           </a:xfrm>
           <a:prstGeom prst="ellipse">
@@ -11323,8 +11323,8 @@
         </p:nvSpPr>
         <p:spPr>
           <a:xfrm>
-            <a:off x="8823959" y="3364991"/>
-            <a:ext cx="2468880" cy="1005840"/>
+            <a:off x="8823960" y="3011119"/>
+            <a:ext cx="2441448" cy="1167688"/>
           </a:xfrm>
           <a:prstGeom prst="rect">
             <a:avLst/>
@@ -11403,8 +11403,8 @@
         </p:nvSpPr>
         <p:spPr>
           <a:xfrm>
-            <a:off x="548640" y="4521592"/>
-            <a:ext cx="3520440" cy="1554711"/>
+            <a:off x="548640" y="4443984"/>
+            <a:ext cx="3520440" cy="1771192"/>
           </a:xfrm>
           <a:prstGeom prst="roundRect">
             <a:avLst>
@@ -11451,7 +11451,7 @@
         </p:nvSpPr>
         <p:spPr>
           <a:xfrm>
-            <a:off x="804672" y="4882896"/>
+            <a:off x="804672" y="4681728"/>
             <a:ext cx="475488" cy="475488"/>
           </a:xfrm>
           <a:prstGeom prst="ellipse">
@@ -11503,8 +11503,8 @@
         </p:nvSpPr>
         <p:spPr>
           <a:xfrm>
-            <a:off x="1417319" y="4846320"/>
-            <a:ext cx="2468880" cy="1005840"/>
+            <a:off x="1417320" y="4663440"/>
+            <a:ext cx="2441448" cy="1396288"/>
           </a:xfrm>
           <a:prstGeom prst="rect">
             <a:avLst/>
@@ -11571,8 +11571,8 @@
         </p:nvSpPr>
         <p:spPr>
           <a:xfrm>
-            <a:off x="4251959" y="4521592"/>
-            <a:ext cx="3520440" cy="1554711"/>
+            <a:off x="4251959" y="4443984"/>
+            <a:ext cx="3520440" cy="1771192"/>
           </a:xfrm>
           <a:prstGeom prst="roundRect">
             <a:avLst>
@@ -11619,7 +11619,7 @@
         </p:nvSpPr>
         <p:spPr>
           <a:xfrm>
-            <a:off x="4507992" y="4882896"/>
+            <a:off x="4507992" y="4681728"/>
             <a:ext cx="475488" cy="475488"/>
           </a:xfrm>
           <a:prstGeom prst="ellipse">
@@ -11671,8 +11671,8 @@
         </p:nvSpPr>
         <p:spPr>
           <a:xfrm>
-            <a:off x="5120640" y="4846320"/>
-            <a:ext cx="2468880" cy="1005840"/>
+            <a:off x="5120640" y="4663440"/>
+            <a:ext cx="2441448" cy="1396288"/>
           </a:xfrm>
           <a:prstGeom prst="rect">
             <a:avLst/>
@@ -11748,8 +11748,8 @@
         </p:nvSpPr>
         <p:spPr>
           <a:xfrm>
-            <a:off x="7955279" y="4521592"/>
-            <a:ext cx="3520440" cy="1554711"/>
+            <a:off x="7955279" y="4443984"/>
+            <a:ext cx="3520440" cy="1771192"/>
           </a:xfrm>
           <a:prstGeom prst="roundRect">
             <a:avLst>
@@ -11796,7 +11796,7 @@
         </p:nvSpPr>
         <p:spPr>
           <a:xfrm>
-            <a:off x="8211311" y="4882896"/>
+            <a:off x="8211312" y="4681728"/>
             <a:ext cx="475488" cy="475488"/>
           </a:xfrm>
           <a:prstGeom prst="ellipse">
@@ -11848,8 +11848,8 @@
         </p:nvSpPr>
         <p:spPr>
           <a:xfrm>
-            <a:off x="8823959" y="4846320"/>
-            <a:ext cx="2468880" cy="1005840"/>
+            <a:off x="8823960" y="4663440"/>
+            <a:ext cx="2441448" cy="1396288"/>
           </a:xfrm>
           <a:prstGeom prst="rect">
             <a:avLst/>
@@ -11942,7 +11942,7 @@
         </p:blipFill>
         <p:spPr>
           <a:xfrm>
-            <a:off x="1801060" y="1603630"/>
+            <a:off x="620877" y="1505102"/>
             <a:ext cx="1021900" cy="1016126"/>
           </a:xfrm>
           <a:prstGeom prst="ellipse">
@@ -11954,7 +11954,7 @@
             </a:solidFill>
           </a:ln>
           <a:effectLst>
-            <a:outerShdw blurRad="381000" dist="292100" dir="5400000" sx="-80000" sy="-18000" rotWithShape="0">
+            <a:outerShdw blurRad="54864" dist="36576" dir="5400000" sx="-80000" sy="-18000" rotWithShape="0">
               <a:srgbClr val="000000">
                 <a:alpha val="22000"/>
               </a:srgbClr>
@@ -11996,7 +11996,7 @@
         </p:blipFill>
         <p:spPr>
           <a:xfrm>
-            <a:off x="6583625" y="1568196"/>
+            <a:off x="6306616" y="1442008"/>
             <a:ext cx="1132387" cy="1143000"/>
           </a:xfrm>
           <a:prstGeom prst="ellipse">
@@ -12008,7 +12008,7 @@
             </a:solidFill>
           </a:ln>
           <a:effectLst>
-            <a:outerShdw blurRad="381000" dist="292100" dir="5400000" sx="-80000" sy="-18000" rotWithShape="0">
+            <a:outerShdw blurRad="54864" dist="36576" dir="5400000" sx="-80000" sy="-18000" rotWithShape="0">
               <a:srgbClr val="000000">
                 <a:alpha val="22000"/>
               </a:srgbClr>
@@ -12070,7 +12070,7 @@
         <p:spPr>
           <a:xfrm>
             <a:off x="411480" y="228600"/>
-            <a:ext cx="7315200" cy="457200"/>
+            <a:ext cx="7315200" cy="536752"/>
           </a:xfrm>
           <a:prstGeom prst="rect">
             <a:avLst/>
@@ -12240,7 +12240,7 @@
         <p:spPr>
           <a:xfrm>
             <a:off x="411480" y="228600"/>
-            <a:ext cx="7315200" cy="457200"/>
+            <a:ext cx="7315200" cy="536752"/>
           </a:xfrm>
           <a:prstGeom prst="rect">
             <a:avLst/>
@@ -12410,7 +12410,7 @@
         <p:spPr>
           <a:xfrm>
             <a:off x="411480" y="228600"/>
-            <a:ext cx="7315200" cy="457200"/>
+            <a:ext cx="7315200" cy="536752"/>
           </a:xfrm>
           <a:prstGeom prst="rect">
             <a:avLst/>
@@ -13643,7 +13643,7 @@
         <p:spPr>
           <a:xfrm>
             <a:off x="548640" y="2103120"/>
-            <a:ext cx="5394960" cy="2697480"/>
+            <a:ext cx="5394960" cy="2457907"/>
           </a:xfrm>
           <a:prstGeom prst="roundRect">
             <a:avLst>
@@ -13690,7 +13690,7 @@
         </p:nvSpPr>
         <p:spPr>
           <a:xfrm>
-            <a:off x="804672" y="2194560"/>
+            <a:off x="804672" y="2139696"/>
             <a:ext cx="475488" cy="475488"/>
           </a:xfrm>
           <a:prstGeom prst="ellipse">
@@ -13743,7 +13743,7 @@
         <p:spPr>
           <a:xfrm>
             <a:off x="1417319" y="2139696"/>
-            <a:ext cx="4343400" cy="2103120"/>
+            <a:ext cx="4315968" cy="2211019"/>
           </a:xfrm>
           <a:prstGeom prst="rect">
             <a:avLst/>
@@ -13851,7 +13851,7 @@
         <p:spPr>
           <a:xfrm>
             <a:off x="6245352" y="2103120"/>
-            <a:ext cx="5394960" cy="2697480"/>
+            <a:ext cx="5394960" cy="2306116"/>
           </a:xfrm>
           <a:prstGeom prst="roundRect">
             <a:avLst>
@@ -13898,7 +13898,7 @@
         </p:nvSpPr>
         <p:spPr>
           <a:xfrm>
-            <a:off x="6501384" y="2194560"/>
+            <a:off x="6501384" y="2139696"/>
             <a:ext cx="475488" cy="475488"/>
           </a:xfrm>
           <a:prstGeom prst="ellipse">
@@ -13951,7 +13951,7 @@
         <p:spPr>
           <a:xfrm>
             <a:off x="7114032" y="2139696"/>
-            <a:ext cx="4343400" cy="2103120"/>
+            <a:ext cx="4315968" cy="2059228"/>
           </a:xfrm>
           <a:prstGeom prst="rect">
             <a:avLst/>
@@ -14204,8 +14204,8 @@
         </p:nvSpPr>
         <p:spPr>
           <a:xfrm>
-            <a:off x="548640" y="1170432"/>
-            <a:ext cx="11091672" cy="292608"/>
+            <a:off x="548640" y="1289304"/>
+            <a:ext cx="11091672" cy="246888"/>
           </a:xfrm>
           <a:prstGeom prst="rect">
             <a:avLst/>
@@ -17991,7 +17991,7 @@
         <p:spPr>
           <a:xfrm>
             <a:off x="640080" y="320040"/>
-            <a:ext cx="5029200" cy="502920"/>
+            <a:ext cx="5029200" cy="585216"/>
           </a:xfrm>
           <a:prstGeom prst="rect">
             <a:avLst/>
@@ -18047,8 +18047,8 @@
           </p:nvPr>
         </p:nvGraphicFramePr>
         <p:xfrm>
-          <a:off x="1003895" y="1028700"/>
-          <a:ext cx="9966957" cy="1691640"/>
+          <a:off x="548640" y="1028700"/>
+          <a:ext cx="11091668" cy="1228039"/>
         </p:xfrm>
         <a:graphic>
           <a:graphicData uri="http://schemas.openxmlformats.org/drawingml/2006/table">
@@ -18057,49 +18057,49 @@
                 <a:tableStyleId>{5C22544A-7EE6-4342-B048-85BDC9FD1C3A}</a:tableStyleId>
               </a:tblPr>
               <a:tblGrid>
-                <a:gridCol w="1423851">
+                <a:gridCol w="1584524">
                   <a:extLst>
                     <a:ext uri="{9D8B030D-6E8A-4147-A177-3AD203B41FA5}">
                       <a16:colId xmlns:a16="http://schemas.microsoft.com/office/drawing/2014/main" val="20000"/>
                     </a:ext>
                   </a:extLst>
                 </a:gridCol>
-                <a:gridCol w="1423851">
+                <a:gridCol w="1584524">
                   <a:extLst>
                     <a:ext uri="{9D8B030D-6E8A-4147-A177-3AD203B41FA5}">
                       <a16:colId xmlns:a16="http://schemas.microsoft.com/office/drawing/2014/main" val="20001"/>
                     </a:ext>
                   </a:extLst>
                 </a:gridCol>
-                <a:gridCol w="1423851">
+                <a:gridCol w="1584524">
                   <a:extLst>
                     <a:ext uri="{9D8B030D-6E8A-4147-A177-3AD203B41FA5}">
                       <a16:colId xmlns:a16="http://schemas.microsoft.com/office/drawing/2014/main" val="20002"/>
                     </a:ext>
                   </a:extLst>
                 </a:gridCol>
-                <a:gridCol w="1423851">
+                <a:gridCol w="1584524">
                   <a:extLst>
                     <a:ext uri="{9D8B030D-6E8A-4147-A177-3AD203B41FA5}">
                       <a16:colId xmlns:a16="http://schemas.microsoft.com/office/drawing/2014/main" val="20003"/>
                     </a:ext>
                   </a:extLst>
                 </a:gridCol>
-                <a:gridCol w="1423851">
+                <a:gridCol w="1584524">
                   <a:extLst>
                     <a:ext uri="{9D8B030D-6E8A-4147-A177-3AD203B41FA5}">
                       <a16:colId xmlns:a16="http://schemas.microsoft.com/office/drawing/2014/main" val="20004"/>
                     </a:ext>
                   </a:extLst>
                 </a:gridCol>
-                <a:gridCol w="1423851">
+                <a:gridCol w="1584524">
                   <a:extLst>
                     <a:ext uri="{9D8B030D-6E8A-4147-A177-3AD203B41FA5}">
                       <a16:colId xmlns:a16="http://schemas.microsoft.com/office/drawing/2014/main" val="20005"/>
                     </a:ext>
                   </a:extLst>
                 </a:gridCol>
-                <a:gridCol w="1423851">
+                <a:gridCol w="1584524">
                   <a:extLst>
                     <a:ext uri="{9D8B030D-6E8A-4147-A177-3AD203B41FA5}">
                       <a16:colId xmlns:a16="http://schemas.microsoft.com/office/drawing/2014/main" val="20006"/>
@@ -18107,7 +18107,7 @@
                   </a:extLst>
                 </a:gridCol>
               </a:tblGrid>
-              <a:tr h="845820">
+              <a:tr h="868680">
                 <a:tc>
                   <a:txBody>
                     <a:bodyPr/>
@@ -18443,7 +18443,7 @@
                   </a:ext>
                 </a:extLst>
               </a:tr>
-              <a:tr h="845820">
+              <a:tr h="359359">
                 <a:tc>
                   <a:txBody>
                     <a:bodyPr wrap="square" lIns="54864" rIns="54864" tIns="27432" bIns="27432" anchor="ctr"/>
@@ -18623,8 +18623,8 @@
         </p:nvSpPr>
         <p:spPr>
           <a:xfrm>
-            <a:off x="1010703" y="2743200"/>
-            <a:ext cx="4480560" cy="347472"/>
+            <a:off x="548640" y="2761488"/>
+            <a:ext cx="4480560" cy="356616"/>
           </a:xfrm>
           <a:prstGeom prst="rect">
             <a:avLst/>
@@ -18673,8 +18673,8 @@
         </p:nvSpPr>
         <p:spPr>
           <a:xfrm>
-            <a:off x="1010703" y="3127248"/>
-            <a:ext cx="4480560" cy="685800"/>
+            <a:off x="548640" y="3136392"/>
+            <a:ext cx="4480560" cy="1008583"/>
           </a:xfrm>
           <a:prstGeom prst="rect">
             <a:avLst/>
@@ -18723,8 +18723,8 @@
         </p:nvSpPr>
         <p:spPr>
           <a:xfrm>
-            <a:off x="1010703" y="4160520"/>
-            <a:ext cx="4480560" cy="347472"/>
+            <a:off x="548640" y="4419600"/>
+            <a:ext cx="4480560" cy="356616"/>
           </a:xfrm>
           <a:prstGeom prst="rect">
             <a:avLst/>
@@ -18773,8 +18773,8 @@
         </p:nvSpPr>
         <p:spPr>
           <a:xfrm>
-            <a:off x="1010703" y="4544568"/>
-            <a:ext cx="4480560" cy="685800"/>
+            <a:off x="548640" y="4794199"/>
+            <a:ext cx="4480560" cy="1008583"/>
           </a:xfrm>
           <a:prstGeom prst="rect">
             <a:avLst/>
@@ -18823,8 +18823,8 @@
         </p:nvSpPr>
         <p:spPr>
           <a:xfrm>
-            <a:off x="5948463" y="2743200"/>
-            <a:ext cx="4480560" cy="347472"/>
+            <a:off x="6245352" y="2761488"/>
+            <a:ext cx="4480560" cy="356616"/>
           </a:xfrm>
           <a:prstGeom prst="rect">
             <a:avLst/>
@@ -18873,8 +18873,8 @@
         </p:nvSpPr>
         <p:spPr>
           <a:xfrm>
-            <a:off x="5948463" y="3127248"/>
-            <a:ext cx="4480560" cy="685800"/>
+            <a:off x="6245352" y="3136392"/>
+            <a:ext cx="4480560" cy="1008583"/>
           </a:xfrm>
           <a:prstGeom prst="rect">
             <a:avLst/>
@@ -18923,8 +18923,8 @@
         </p:nvSpPr>
         <p:spPr>
           <a:xfrm>
-            <a:off x="5948463" y="4160520"/>
-            <a:ext cx="4480560" cy="347472"/>
+            <a:off x="6245352" y="4419600"/>
+            <a:ext cx="4480560" cy="356616"/>
           </a:xfrm>
           <a:prstGeom prst="rect">
             <a:avLst/>
@@ -18973,8 +18973,8 @@
         </p:nvSpPr>
         <p:spPr>
           <a:xfrm>
-            <a:off x="5948463" y="4544568"/>
-            <a:ext cx="4480560" cy="685800"/>
+            <a:off x="6245352" y="4794199"/>
+            <a:ext cx="4480560" cy="1008583"/>
           </a:xfrm>
           <a:prstGeom prst="rect">
             <a:avLst/>
@@ -19024,7 +19024,7 @@
         <p:spPr>
           <a:xfrm>
             <a:off x="411480" y="6419088"/>
-            <a:ext cx="2743200" cy="182880"/>
+            <a:ext cx="2743200" cy="237744"/>
           </a:xfrm>
           <a:prstGeom prst="rect">
             <a:avLst/>
@@ -19074,7 +19074,7 @@
         <p:spPr>
           <a:xfrm>
             <a:off x="5486400" y="6419088"/>
-            <a:ext cx="2743200" cy="182880"/>
+            <a:ext cx="2743200" cy="237744"/>
           </a:xfrm>
           <a:prstGeom prst="rect">
             <a:avLst/>
@@ -19236,7 +19236,7 @@
         <p:spPr>
           <a:xfrm>
             <a:off x="640080" y="320040"/>
-            <a:ext cx="5303520" cy="502920"/>
+            <a:ext cx="5303520" cy="585216"/>
           </a:xfrm>
           <a:prstGeom prst="rect">
             <a:avLst/>
@@ -19292,8 +19292,8 @@
           </p:nvPr>
         </p:nvGraphicFramePr>
         <p:xfrm>
-          <a:off x="1035996" y="963717"/>
-          <a:ext cx="9144000" cy="1219653"/>
+          <a:off x="548640" y="963717"/>
+          <a:ext cx="11091670" cy="1456639"/>
         </p:xfrm>
         <a:graphic>
           <a:graphicData uri="http://schemas.openxmlformats.org/drawingml/2006/table">
@@ -19302,35 +19302,35 @@
                 <a:tableStyleId>{5C22544A-7EE6-4342-B048-85BDC9FD1C3A}</a:tableStyleId>
               </a:tblPr>
               <a:tblGrid>
-                <a:gridCol w="1828800">
+                <a:gridCol w="2218334">
                   <a:extLst>
                     <a:ext uri="{9D8B030D-6E8A-4147-A177-3AD203B41FA5}">
                       <a16:colId xmlns:a16="http://schemas.microsoft.com/office/drawing/2014/main" val="20000"/>
                     </a:ext>
                   </a:extLst>
                 </a:gridCol>
-                <a:gridCol w="1828800">
+                <a:gridCol w="2218334">
                   <a:extLst>
                     <a:ext uri="{9D8B030D-6E8A-4147-A177-3AD203B41FA5}">
                       <a16:colId xmlns:a16="http://schemas.microsoft.com/office/drawing/2014/main" val="20001"/>
                     </a:ext>
                   </a:extLst>
                 </a:gridCol>
-                <a:gridCol w="1828800">
+                <a:gridCol w="2218334">
                   <a:extLst>
                     <a:ext uri="{9D8B030D-6E8A-4147-A177-3AD203B41FA5}">
                       <a16:colId xmlns:a16="http://schemas.microsoft.com/office/drawing/2014/main" val="20002"/>
                     </a:ext>
                   </a:extLst>
                 </a:gridCol>
-                <a:gridCol w="1828800">
+                <a:gridCol w="2218334">
                   <a:extLst>
                     <a:ext uri="{9D8B030D-6E8A-4147-A177-3AD203B41FA5}">
                       <a16:colId xmlns:a16="http://schemas.microsoft.com/office/drawing/2014/main" val="20003"/>
                     </a:ext>
                   </a:extLst>
                 </a:gridCol>
-                <a:gridCol w="1828800">
+                <a:gridCol w="2218334">
                   <a:extLst>
                     <a:ext uri="{9D8B030D-6E8A-4147-A177-3AD203B41FA5}">
                       <a16:colId xmlns:a16="http://schemas.microsoft.com/office/drawing/2014/main" val="20004"/>
@@ -19338,7 +19338,7 @@
                   </a:extLst>
                 </a:gridCol>
               </a:tblGrid>
-              <a:tr h="559826">
+              <a:tr h="1097280">
                 <a:tc>
                   <a:txBody>
                     <a:bodyPr/>
@@ -19568,7 +19568,7 @@
                   </a:ext>
                 </a:extLst>
               </a:tr>
-              <a:tr h="659827">
+              <a:tr h="359359">
                 <a:tc>
                   <a:txBody>
                     <a:bodyPr wrap="square" lIns="54864" rIns="54864" tIns="27432" bIns="27432" anchor="ctr"/>
@@ -19702,8 +19702,8 @@
         </p:nvSpPr>
         <p:spPr>
           <a:xfrm>
-            <a:off x="1039886" y="2743202"/>
-            <a:ext cx="4480560" cy="347472"/>
+            <a:off x="548640" y="2761488"/>
+            <a:ext cx="4480560" cy="356616"/>
           </a:xfrm>
           <a:prstGeom prst="rect">
             <a:avLst/>
@@ -19752,8 +19752,8 @@
         </p:nvSpPr>
         <p:spPr>
           <a:xfrm>
-            <a:off x="1039886" y="3127250"/>
-            <a:ext cx="4480560" cy="685800"/>
+            <a:off x="548640" y="3136392"/>
+            <a:ext cx="4480560" cy="795528"/>
           </a:xfrm>
           <a:prstGeom prst="rect">
             <a:avLst/>
@@ -19802,8 +19802,8 @@
         </p:nvSpPr>
         <p:spPr>
           <a:xfrm>
-            <a:off x="1039886" y="4160522"/>
-            <a:ext cx="4480560" cy="347472"/>
+            <a:off x="548640" y="4206240"/>
+            <a:ext cx="4480560" cy="356616"/>
           </a:xfrm>
           <a:prstGeom prst="rect">
             <a:avLst/>
@@ -19852,8 +19852,8 @@
         </p:nvSpPr>
         <p:spPr>
           <a:xfrm>
-            <a:off x="1039886" y="4544570"/>
-            <a:ext cx="4480560" cy="685800"/>
+            <a:off x="548640" y="4581144"/>
+            <a:ext cx="4480560" cy="795528"/>
           </a:xfrm>
           <a:prstGeom prst="rect">
             <a:avLst/>
@@ -19902,8 +19902,8 @@
         </p:nvSpPr>
         <p:spPr>
           <a:xfrm>
-            <a:off x="5977646" y="2743202"/>
-            <a:ext cx="4480560" cy="347472"/>
+            <a:off x="6245352" y="2761488"/>
+            <a:ext cx="4480560" cy="356616"/>
           </a:xfrm>
           <a:prstGeom prst="rect">
             <a:avLst/>
@@ -19952,8 +19952,8 @@
         </p:nvSpPr>
         <p:spPr>
           <a:xfrm>
-            <a:off x="5977646" y="3127250"/>
-            <a:ext cx="4480560" cy="685800"/>
+            <a:off x="6245352" y="3136392"/>
+            <a:ext cx="4480560" cy="795528"/>
           </a:xfrm>
           <a:prstGeom prst="rect">
             <a:avLst/>
@@ -20002,8 +20002,8 @@
         </p:nvSpPr>
         <p:spPr>
           <a:xfrm>
-            <a:off x="5977646" y="4160522"/>
-            <a:ext cx="4480560" cy="347472"/>
+            <a:off x="6245352" y="4206240"/>
+            <a:ext cx="4480560" cy="356616"/>
           </a:xfrm>
           <a:prstGeom prst="rect">
             <a:avLst/>
@@ -20052,8 +20052,8 @@
         </p:nvSpPr>
         <p:spPr>
           <a:xfrm>
-            <a:off x="5977646" y="4544570"/>
-            <a:ext cx="4480560" cy="685800"/>
+            <a:off x="6245352" y="4581144"/>
+            <a:ext cx="4480560" cy="795528"/>
           </a:xfrm>
           <a:prstGeom prst="rect">
             <a:avLst/>
@@ -20103,7 +20103,7 @@
         <p:spPr>
           <a:xfrm>
             <a:off x="411480" y="6419088"/>
-            <a:ext cx="2743200" cy="182880"/>
+            <a:ext cx="2743200" cy="237744"/>
           </a:xfrm>
           <a:prstGeom prst="rect">
             <a:avLst/>
@@ -20153,7 +20153,7 @@
         <p:spPr>
           <a:xfrm>
             <a:off x="5486400" y="6419088"/>
-            <a:ext cx="2743200" cy="182880"/>
+            <a:ext cx="2743200" cy="237744"/>
           </a:xfrm>
           <a:prstGeom prst="rect">
             <a:avLst/>
@@ -20419,8 +20419,8 @@
         </p:nvSpPr>
         <p:spPr>
           <a:xfrm>
-            <a:off x="548640" y="1783080"/>
-            <a:ext cx="5394960" cy="3246120"/>
+            <a:off x="548640" y="1920240"/>
+            <a:ext cx="5394960" cy="3537813"/>
           </a:xfrm>
           <a:prstGeom prst="roundRect">
             <a:avLst>
@@ -20467,7 +20467,7 @@
         </p:nvSpPr>
         <p:spPr>
           <a:xfrm>
-            <a:off x="804672" y="2020824"/>
+            <a:off x="804672" y="2057400"/>
             <a:ext cx="475488" cy="475488"/>
           </a:xfrm>
           <a:prstGeom prst="ellipse">
@@ -20519,8 +20519,8 @@
         </p:nvSpPr>
         <p:spPr>
           <a:xfrm>
-            <a:off x="1417319" y="2020824"/>
-            <a:ext cx="4343400" cy="2770632"/>
+            <a:off x="1417320" y="2167128"/>
+            <a:ext cx="4315968" cy="3071469"/>
           </a:xfrm>
           <a:prstGeom prst="rect">
             <a:avLst/>
@@ -20615,8 +20615,8 @@
         </p:nvSpPr>
         <p:spPr>
           <a:xfrm>
-            <a:off x="6245352" y="1783080"/>
-            <a:ext cx="5394960" cy="3246120"/>
+            <a:off x="6245352" y="1920240"/>
+            <a:ext cx="5394960" cy="3537813"/>
           </a:xfrm>
           <a:prstGeom prst="roundRect">
             <a:avLst>
@@ -20663,7 +20663,7 @@
         </p:nvSpPr>
         <p:spPr>
           <a:xfrm>
-            <a:off x="6501384" y="2020824"/>
+            <a:off x="6501384" y="2057400"/>
             <a:ext cx="475488" cy="475488"/>
           </a:xfrm>
           <a:prstGeom prst="ellipse">
@@ -20715,8 +20715,8 @@
         </p:nvSpPr>
         <p:spPr>
           <a:xfrm>
-            <a:off x="7114032" y="2020824"/>
-            <a:ext cx="4343400" cy="2770632"/>
+            <a:off x="7114032" y="3081528"/>
+            <a:ext cx="4315968" cy="2157069"/>
           </a:xfrm>
           <a:prstGeom prst="rect">
             <a:avLst/>
@@ -21496,8 +21496,8 @@
         </p:nvSpPr>
         <p:spPr>
           <a:xfrm>
-            <a:off x="548640" y="2469608"/>
-            <a:ext cx="5394960" cy="2056779"/>
+            <a:off x="548640" y="2340864"/>
+            <a:ext cx="5394960" cy="2763316"/>
           </a:xfrm>
           <a:prstGeom prst="roundRect">
             <a:avLst>
@@ -21544,7 +21544,7 @@
         </p:nvSpPr>
         <p:spPr>
           <a:xfrm>
-            <a:off x="804672" y="2420560"/>
+            <a:off x="804672" y="2478024"/>
             <a:ext cx="475488" cy="475488"/>
           </a:xfrm>
           <a:prstGeom prst="ellipse">
@@ -21596,8 +21596,8 @@
         </p:nvSpPr>
         <p:spPr>
           <a:xfrm>
-            <a:off x="1417319" y="2383984"/>
-            <a:ext cx="4343400" cy="1831286"/>
+            <a:off x="1417320" y="2587752"/>
+            <a:ext cx="4315968" cy="2296972"/>
           </a:xfrm>
           <a:prstGeom prst="rect">
             <a:avLst/>
@@ -21680,8 +21680,8 @@
         </p:nvSpPr>
         <p:spPr>
           <a:xfrm>
-            <a:off x="6245352" y="2469608"/>
-            <a:ext cx="5394960" cy="2056779"/>
+            <a:off x="6245352" y="2340864"/>
+            <a:ext cx="5394960" cy="2763316"/>
           </a:xfrm>
           <a:prstGeom prst="roundRect">
             <a:avLst>
@@ -21728,7 +21728,7 @@
         </p:nvSpPr>
         <p:spPr>
           <a:xfrm>
-            <a:off x="6501384" y="2078904"/>
+            <a:off x="6501384" y="2478024"/>
             <a:ext cx="475488" cy="475488"/>
           </a:xfrm>
           <a:prstGeom prst="ellipse">
@@ -21780,8 +21780,8 @@
         </p:nvSpPr>
         <p:spPr>
           <a:xfrm>
-            <a:off x="7114032" y="2042328"/>
-            <a:ext cx="4343400" cy="2514600"/>
+            <a:off x="7114032" y="2969056"/>
+            <a:ext cx="4315968" cy="1915668"/>
           </a:xfrm>
           <a:prstGeom prst="rect">
             <a:avLst/>
@@ -21932,8 +21932,8 @@
         </p:nvSpPr>
         <p:spPr>
           <a:xfrm>
-            <a:off x="548640" y="5029200"/>
-            <a:ext cx="11064240" cy="914400"/>
+            <a:off x="548640" y="5268772"/>
+            <a:ext cx="11064240" cy="749808"/>
           </a:xfrm>
           <a:prstGeom prst="rect">
             <a:avLst/>
@@ -22146,8 +22146,8 @@
         </p:nvSpPr>
         <p:spPr>
           <a:xfrm>
-            <a:off x="548640" y="6309360"/>
-            <a:ext cx="11064240" cy="365760"/>
+            <a:off x="548640" y="5992063"/>
+            <a:ext cx="11064240" cy="262432"/>
           </a:xfrm>
           <a:prstGeom prst="rect">
             <a:avLst/>
@@ -22610,8 +22610,8 @@
         </p:nvSpPr>
         <p:spPr>
           <a:xfrm>
-            <a:off x="548640" y="1170432"/>
-            <a:ext cx="11091672" cy="384048"/>
+            <a:off x="548640" y="1289304"/>
+            <a:ext cx="11091672" cy="246888"/>
           </a:xfrm>
           <a:prstGeom prst="rect">
             <a:avLst/>
@@ -22788,7 +22788,7 @@
         <p:spPr>
           <a:xfrm>
             <a:off x="768096" y="3035808"/>
-            <a:ext cx="2141982" cy="1271016"/>
+            <a:ext cx="2159812" cy="1140256"/>
           </a:xfrm>
           <a:prstGeom prst="rect">
             <a:avLst/>
@@ -22969,7 +22969,7 @@
         <p:spPr>
           <a:xfrm>
             <a:off x="3605022" y="3035808"/>
-            <a:ext cx="2141982" cy="1271016"/>
+            <a:ext cx="2159812" cy="1140256"/>
           </a:xfrm>
           <a:prstGeom prst="rect">
             <a:avLst/>
@@ -23150,7 +23150,7 @@
         <p:spPr>
           <a:xfrm>
             <a:off x="6441948" y="3035808"/>
-            <a:ext cx="2141982" cy="1271016"/>
+            <a:ext cx="2159812" cy="1140256"/>
           </a:xfrm>
           <a:prstGeom prst="rect">
             <a:avLst/>
@@ -23331,7 +23331,7 @@
         <p:spPr>
           <a:xfrm>
             <a:off x="9278874" y="3035808"/>
-            <a:ext cx="2141982" cy="1271016"/>
+            <a:ext cx="2159812" cy="1140256"/>
           </a:xfrm>
           <a:prstGeom prst="rect">
             <a:avLst/>
@@ -24176,8 +24176,8 @@
         </p:nvSpPr>
         <p:spPr>
           <a:xfrm>
-            <a:off x="548640" y="1573710"/>
-            <a:ext cx="3520440" cy="1817766"/>
+            <a:off x="548640" y="1573682"/>
+            <a:ext cx="3520440" cy="1988820"/>
           </a:xfrm>
           <a:prstGeom prst="roundRect">
             <a:avLst>
@@ -24224,7 +24224,7 @@
         </p:nvSpPr>
         <p:spPr>
           <a:xfrm>
-            <a:off x="804672" y="1857293"/>
+            <a:off x="804672" y="1857146"/>
             <a:ext cx="475488" cy="475488"/>
           </a:xfrm>
           <a:prstGeom prst="ellipse">
@@ -24276,8 +24276,8 @@
         </p:nvSpPr>
         <p:spPr>
           <a:xfrm>
-            <a:off x="1417319" y="1820717"/>
-            <a:ext cx="2468880" cy="1508760"/>
+            <a:off x="1417320" y="1838858"/>
+            <a:ext cx="2441448" cy="1632204"/>
           </a:xfrm>
           <a:prstGeom prst="rect">
             <a:avLst/>
@@ -24328,8 +24328,8 @@
         </p:nvSpPr>
         <p:spPr>
           <a:xfrm>
-            <a:off x="4251959" y="1573710"/>
-            <a:ext cx="3520440" cy="1817766"/>
+            <a:off x="4251959" y="1573682"/>
+            <a:ext cx="3520440" cy="1988820"/>
           </a:xfrm>
           <a:prstGeom prst="roundRect">
             <a:avLst>
@@ -24376,7 +24376,7 @@
         </p:nvSpPr>
         <p:spPr>
           <a:xfrm>
-            <a:off x="4507992" y="1857293"/>
+            <a:off x="4507992" y="1857146"/>
             <a:ext cx="475488" cy="475488"/>
           </a:xfrm>
           <a:prstGeom prst="ellipse">
@@ -24428,8 +24428,8 @@
         </p:nvSpPr>
         <p:spPr>
           <a:xfrm>
-            <a:off x="5120640" y="1820717"/>
-            <a:ext cx="2468880" cy="1508760"/>
+            <a:off x="5120640" y="1838858"/>
+            <a:ext cx="2441448" cy="1403604"/>
           </a:xfrm>
           <a:prstGeom prst="rect">
             <a:avLst/>
@@ -24492,8 +24492,8 @@
         </p:nvSpPr>
         <p:spPr>
           <a:xfrm>
-            <a:off x="7955279" y="1573710"/>
-            <a:ext cx="3520440" cy="1817766"/>
+            <a:off x="7955279" y="1573682"/>
+            <a:ext cx="3520440" cy="1988820"/>
           </a:xfrm>
           <a:prstGeom prst="roundRect">
             <a:avLst>
@@ -24540,7 +24540,7 @@
         </p:nvSpPr>
         <p:spPr>
           <a:xfrm>
-            <a:off x="8211311" y="1857293"/>
+            <a:off x="8211311" y="1857146"/>
             <a:ext cx="475488" cy="475488"/>
           </a:xfrm>
           <a:prstGeom prst="ellipse">
@@ -24592,8 +24592,8 @@
         </p:nvSpPr>
         <p:spPr>
           <a:xfrm>
-            <a:off x="8823959" y="1820717"/>
-            <a:ext cx="2468880" cy="1508760"/>
+            <a:off x="8823959" y="1838858"/>
+            <a:ext cx="2441448" cy="1403604"/>
           </a:xfrm>
           <a:prstGeom prst="rect">
             <a:avLst/>
@@ -24656,8 +24656,8 @@
         </p:nvSpPr>
         <p:spPr>
           <a:xfrm>
-            <a:off x="548640" y="4012758"/>
-            <a:ext cx="3520440" cy="1538422"/>
+            <a:off x="548640" y="3608222"/>
+            <a:ext cx="3520440" cy="1760220"/>
           </a:xfrm>
           <a:prstGeom prst="roundRect">
             <a:avLst>
@@ -24704,7 +24704,7 @@
         </p:nvSpPr>
         <p:spPr>
           <a:xfrm>
-            <a:off x="804672" y="4240297"/>
+            <a:off x="804672" y="3891686"/>
             <a:ext cx="475488" cy="475488"/>
           </a:xfrm>
           <a:prstGeom prst="ellipse">
@@ -24756,8 +24756,8 @@
         </p:nvSpPr>
         <p:spPr>
           <a:xfrm>
-            <a:off x="1417319" y="4203721"/>
-            <a:ext cx="2468880" cy="1036761"/>
+            <a:off x="1417320" y="3873398"/>
+            <a:ext cx="2441448" cy="1403604"/>
           </a:xfrm>
           <a:prstGeom prst="rect">
             <a:avLst/>
@@ -24820,8 +24820,8 @@
         </p:nvSpPr>
         <p:spPr>
           <a:xfrm>
-            <a:off x="4251959" y="4012758"/>
-            <a:ext cx="3520440" cy="1538422"/>
+            <a:off x="4251959" y="3608222"/>
+            <a:ext cx="3520440" cy="1760220"/>
           </a:xfrm>
           <a:prstGeom prst="roundRect">
             <a:avLst>
@@ -24868,7 +24868,7 @@
         </p:nvSpPr>
         <p:spPr>
           <a:xfrm>
-            <a:off x="4507992" y="4004298"/>
+            <a:off x="4507992" y="3891686"/>
             <a:ext cx="475488" cy="475488"/>
           </a:xfrm>
           <a:prstGeom prst="ellipse">
@@ -24920,8 +24920,8 @@
         </p:nvSpPr>
         <p:spPr>
           <a:xfrm>
-            <a:off x="5120640" y="3967722"/>
-            <a:ext cx="2468880" cy="1508760"/>
+            <a:off x="5120640" y="3873398"/>
+            <a:ext cx="2441448" cy="1175004"/>
           </a:xfrm>
           <a:prstGeom prst="rect">
             <a:avLst/>
@@ -24972,8 +24972,8 @@
         </p:nvSpPr>
         <p:spPr>
           <a:xfrm>
-            <a:off x="7955279" y="4012758"/>
-            <a:ext cx="3520440" cy="1538422"/>
+            <a:off x="7955279" y="3608222"/>
+            <a:ext cx="3520440" cy="1760220"/>
           </a:xfrm>
           <a:prstGeom prst="roundRect">
             <a:avLst>
@@ -25020,7 +25020,7 @@
         </p:nvSpPr>
         <p:spPr>
           <a:xfrm>
-            <a:off x="8211311" y="4004298"/>
+            <a:off x="8211311" y="3891686"/>
             <a:ext cx="475488" cy="475488"/>
           </a:xfrm>
           <a:prstGeom prst="ellipse">
@@ -25072,8 +25072,8 @@
         </p:nvSpPr>
         <p:spPr>
           <a:xfrm>
-            <a:off x="8823959" y="3967722"/>
-            <a:ext cx="2468880" cy="1508760"/>
+            <a:off x="8823959" y="3873398"/>
+            <a:ext cx="2441448" cy="1403604"/>
           </a:xfrm>
           <a:prstGeom prst="rect">
             <a:avLst/>

</xml_diff>